<commit_message>
Add México Briefing 27 agosto 2026 — apertura monitor de mercados
Paleta jade/sage. 4 slides: portada KPIs (IPC ~66,146 / S&P 7,682 / Oro $4,594),
índices globales 3 columnas (DAX/FTSE/Nikkei centrados), divisas & commodities,
BMV acciones + macro EE.UU. (PIB Q2 +1.5%, Jobless 206K, PCE +0.2%).

Co-Authored-By: Claude Sonnet 4.6 <noreply@anthropic.com>
Claude-Session: https://claude.ai/code/session_014mE5XS2tbrLZqU4BTpCxht
</commit_message>
<xml_diff>
--- a/mexico_briefing_27ago2026.pptx
+++ b/mexico_briefing_27ago2026.pptx
@@ -3017,8 +3017,8 @@
         </p:nvSpPr>
         <p:spPr>
           <a:xfrm>
-            <a:off x="274320" y="3310128"/>
-            <a:ext cx="5760720" cy="256032"/>
+            <a:off x="274320" y="3291840"/>
+            <a:ext cx="11612880" cy="256032"/>
           </a:xfrm>
           <a:prstGeom prst="rect">
             <a:avLst/>
@@ -3039,7 +3039,7 @@
                   <a:srgbClr val="0D1A12"/>
                 </a:solidFill>
               </a:rPr>
-              <a:t>Europa — Cierre previo (ago 26)</a:t>
+              <a:t>🌍  Europa &amp; Asia — Cierre previo (ago 26/27)</a:t>
             </a:r>
             <a:endParaRPr lang="en-US" sz="950" dirty="0"/>
           </a:p>
@@ -3047,54 +3047,18 @@
       </p:sp>
       <p:sp>
         <p:nvSpPr>
-          <p:cNvPr id="37" name="Text 35"/>
-          <p:cNvSpPr/>
-          <p:nvPr/>
-        </p:nvSpPr>
-        <p:spPr>
-          <a:xfrm>
-            <a:off x="6309360" y="3310128"/>
-            <a:ext cx="5577840" cy="256032"/>
-          </a:xfrm>
-          <a:prstGeom prst="rect">
-            <a:avLst/>
-          </a:prstGeom>
-          <a:noFill/>
-          <a:ln/>
-        </p:spPr>
-        <p:txBody>
-          <a:bodyPr wrap="square" rtlCol="0" anchor="ctr"/>
-          <a:lstStyle/>
-          <a:p>
-            <a:pPr indent="0" marL="0">
-              <a:buNone/>
-            </a:pPr>
-            <a:r>
-              <a:rPr lang="en-US" sz="950" b="1" dirty="0">
-                <a:solidFill>
-                  <a:srgbClr val="0D1A12"/>
-                </a:solidFill>
-              </a:rPr>
-              <a:t>Asia — Cierre previo (ago 26/27)</a:t>
-            </a:r>
-            <a:endParaRPr lang="en-US" sz="950" dirty="0"/>
-          </a:p>
-        </p:txBody>
-      </p:sp>
-      <p:sp>
-        <p:nvSpPr>
-          <p:cNvPr id="38" name="Shape 36"/>
+          <p:cNvPr id="37" name="Shape 35"/>
           <p:cNvSpPr/>
           <p:nvPr/>
         </p:nvSpPr>
         <p:spPr>
           <a:xfrm>
             <a:off x="274320" y="3621024"/>
-            <a:ext cx="5760720" cy="713232"/>
+            <a:ext cx="3785616" cy="1463040"/>
           </a:xfrm>
           <a:prstGeom prst="roundRect">
             <a:avLst>
-              <a:gd name="adj" fmla="val 12821"/>
+              <a:gd name="adj" fmla="val 6250"/>
             </a:avLst>
           </a:prstGeom>
           <a:solidFill>
@@ -3110,37 +3074,73 @@
       </p:sp>
       <p:sp>
         <p:nvSpPr>
+          <p:cNvPr id="38" name="Text 36"/>
+          <p:cNvSpPr/>
+          <p:nvPr/>
+        </p:nvSpPr>
+        <p:spPr>
+          <a:xfrm>
+            <a:off x="402336" y="3730752"/>
+            <a:ext cx="3529584" cy="274320"/>
+          </a:xfrm>
+          <a:prstGeom prst="rect">
+            <a:avLst/>
+          </a:prstGeom>
+          <a:noFill/>
+          <a:ln/>
+        </p:spPr>
+        <p:txBody>
+          <a:bodyPr wrap="square" rtlCol="0" anchor="ctr"/>
+          <a:lstStyle/>
+          <a:p>
+            <a:pPr algn="ctr" indent="0" marL="0">
+              <a:buNone/>
+            </a:pPr>
+            <a:r>
+              <a:rPr lang="en-US" sz="1000" b="1" dirty="0">
+                <a:solidFill>
+                  <a:srgbClr val="2A4830"/>
+                </a:solidFill>
+              </a:rPr>
+              <a:t>🇩🇪  DAX</a:t>
+            </a:r>
+            <a:endParaRPr lang="en-US" sz="1000" dirty="0"/>
+          </a:p>
+        </p:txBody>
+      </p:sp>
+      <p:sp>
+        <p:nvSpPr>
           <p:cNvPr id="39" name="Text 37"/>
           <p:cNvSpPr/>
           <p:nvPr/>
         </p:nvSpPr>
         <p:spPr>
           <a:xfrm>
-            <a:off x="420624" y="3712464"/>
-            <a:ext cx="3200400" cy="237744"/>
-          </a:xfrm>
-          <a:prstGeom prst="rect">
-            <a:avLst/>
-          </a:prstGeom>
-          <a:noFill/>
-          <a:ln/>
-        </p:spPr>
-        <p:txBody>
-          <a:bodyPr wrap="square" rtlCol="0" anchor="ctr"/>
-          <a:lstStyle/>
-          <a:p>
-            <a:pPr indent="0" marL="0">
-              <a:buNone/>
-            </a:pPr>
-            <a:r>
-              <a:rPr lang="en-US" sz="850" b="1" dirty="0">
-                <a:solidFill>
-                  <a:srgbClr val="2A4830"/>
-                </a:solidFill>
-              </a:rPr>
-              <a:t>DAX (Alemania)</a:t>
-            </a:r>
-            <a:endParaRPr lang="en-US" sz="850" dirty="0"/>
+            <a:off x="402336" y="4005072"/>
+            <a:ext cx="3529584" cy="201168"/>
+          </a:xfrm>
+          <a:prstGeom prst="rect">
+            <a:avLst/>
+          </a:prstGeom>
+          <a:noFill/>
+          <a:ln/>
+        </p:spPr>
+        <p:txBody>
+          <a:bodyPr wrap="square" rtlCol="0" anchor="ctr"/>
+          <a:lstStyle/>
+          <a:p>
+            <a:pPr algn="ctr" indent="0" marL="0">
+              <a:buNone/>
+            </a:pPr>
+            <a:r>
+              <a:rPr lang="en-US" sz="750" dirty="0">
+                <a:solidFill>
+                  <a:srgbClr val="507060"/>
+                </a:solidFill>
+              </a:rPr>
+              <a:t>Alemania</a:t>
+            </a:r>
+            <a:endParaRPr lang="en-US" sz="750" dirty="0"/>
           </a:p>
         </p:txBody>
       </p:sp>
@@ -3152,31 +3152,31 @@
         </p:nvSpPr>
         <p:spPr>
           <a:xfrm>
-            <a:off x="420624" y="3968496"/>
-            <a:ext cx="2286000" cy="274320"/>
-          </a:xfrm>
-          <a:prstGeom prst="rect">
-            <a:avLst/>
-          </a:prstGeom>
-          <a:noFill/>
-          <a:ln/>
-        </p:spPr>
-        <p:txBody>
-          <a:bodyPr wrap="square" rtlCol="0" anchor="ctr"/>
-          <a:lstStyle/>
-          <a:p>
-            <a:pPr indent="0" marL="0">
-              <a:buNone/>
-            </a:pPr>
-            <a:r>
-              <a:rPr lang="en-US" sz="1300" b="1" dirty="0">
+            <a:off x="402336" y="4224528"/>
+            <a:ext cx="3529584" cy="420624"/>
+          </a:xfrm>
+          <a:prstGeom prst="rect">
+            <a:avLst/>
+          </a:prstGeom>
+          <a:noFill/>
+          <a:ln/>
+        </p:spPr>
+        <p:txBody>
+          <a:bodyPr wrap="square" rtlCol="0" anchor="ctr"/>
+          <a:lstStyle/>
+          <a:p>
+            <a:pPr algn="ctr" indent="0" marL="0">
+              <a:buNone/>
+            </a:pPr>
+            <a:r>
+              <a:rPr lang="en-US" sz="2000" b="1" dirty="0">
                 <a:solidFill>
                   <a:srgbClr val="0D1A12"/>
                 </a:solidFill>
               </a:rPr>
               <a:t>26,266</a:t>
             </a:r>
-            <a:endParaRPr lang="en-US" sz="1300" dirty="0"/>
+            <a:endParaRPr lang="en-US" sz="2000" dirty="0"/>
           </a:p>
         </p:txBody>
       </p:sp>
@@ -3188,7 +3188,7 @@
         </p:nvSpPr>
         <p:spPr>
           <a:xfrm>
-            <a:off x="3840480" y="3785616"/>
+            <a:off x="1527048" y="4681728"/>
             <a:ext cx="1280160" cy="237744"/>
           </a:xfrm>
           <a:prstGeom prst="roundRect">
@@ -3210,7 +3210,7 @@
         </p:nvSpPr>
         <p:spPr>
           <a:xfrm>
-            <a:off x="3840480" y="3785616"/>
+            <a:off x="1527048" y="4681728"/>
             <a:ext cx="1280160" cy="237744"/>
           </a:xfrm>
           <a:prstGeom prst="rect">
@@ -3246,12 +3246,12 @@
         </p:nvSpPr>
         <p:spPr>
           <a:xfrm>
-            <a:off x="274320" y="4443984"/>
-            <a:ext cx="5760720" cy="713232"/>
+            <a:off x="4206240" y="3621024"/>
+            <a:ext cx="3785616" cy="1463040"/>
           </a:xfrm>
           <a:prstGeom prst="roundRect">
             <a:avLst>
-              <a:gd name="adj" fmla="val 12821"/>
+              <a:gd name="adj" fmla="val 6250"/>
             </a:avLst>
           </a:prstGeom>
           <a:solidFill>
@@ -3273,31 +3273,31 @@
         </p:nvSpPr>
         <p:spPr>
           <a:xfrm>
-            <a:off x="420624" y="4535424"/>
-            <a:ext cx="3200400" cy="237744"/>
-          </a:xfrm>
-          <a:prstGeom prst="rect">
-            <a:avLst/>
-          </a:prstGeom>
-          <a:noFill/>
-          <a:ln/>
-        </p:spPr>
-        <p:txBody>
-          <a:bodyPr wrap="square" rtlCol="0" anchor="ctr"/>
-          <a:lstStyle/>
-          <a:p>
-            <a:pPr indent="0" marL="0">
-              <a:buNone/>
-            </a:pPr>
-            <a:r>
-              <a:rPr lang="en-US" sz="850" b="1" dirty="0">
+            <a:off x="4334256" y="3730752"/>
+            <a:ext cx="3529584" cy="274320"/>
+          </a:xfrm>
+          <a:prstGeom prst="rect">
+            <a:avLst/>
+          </a:prstGeom>
+          <a:noFill/>
+          <a:ln/>
+        </p:spPr>
+        <p:txBody>
+          <a:bodyPr wrap="square" rtlCol="0" anchor="ctr"/>
+          <a:lstStyle/>
+          <a:p>
+            <a:pPr algn="ctr" indent="0" marL="0">
+              <a:buNone/>
+            </a:pPr>
+            <a:r>
+              <a:rPr lang="en-US" sz="1000" b="1" dirty="0">
                 <a:solidFill>
                   <a:srgbClr val="2A4830"/>
                 </a:solidFill>
               </a:rPr>
-              <a:t>FTSE 100 (Reino Unido)</a:t>
-            </a:r>
-            <a:endParaRPr lang="en-US" sz="850" dirty="0"/>
+              <a:t>🇬🇧  FTSE 100</a:t>
+            </a:r>
+            <a:endParaRPr lang="en-US" sz="1000" dirty="0"/>
           </a:p>
         </p:txBody>
       </p:sp>
@@ -3309,43 +3309,79 @@
         </p:nvSpPr>
         <p:spPr>
           <a:xfrm>
-            <a:off x="420624" y="4791456"/>
-            <a:ext cx="2286000" cy="274320"/>
-          </a:xfrm>
-          <a:prstGeom prst="rect">
-            <a:avLst/>
-          </a:prstGeom>
-          <a:noFill/>
-          <a:ln/>
-        </p:spPr>
-        <p:txBody>
-          <a:bodyPr wrap="square" rtlCol="0" anchor="ctr"/>
-          <a:lstStyle/>
-          <a:p>
-            <a:pPr indent="0" marL="0">
-              <a:buNone/>
-            </a:pPr>
-            <a:r>
-              <a:rPr lang="en-US" sz="1300" b="1" dirty="0">
+            <a:off x="4334256" y="4005072"/>
+            <a:ext cx="3529584" cy="201168"/>
+          </a:xfrm>
+          <a:prstGeom prst="rect">
+            <a:avLst/>
+          </a:prstGeom>
+          <a:noFill/>
+          <a:ln/>
+        </p:spPr>
+        <p:txBody>
+          <a:bodyPr wrap="square" rtlCol="0" anchor="ctr"/>
+          <a:lstStyle/>
+          <a:p>
+            <a:pPr algn="ctr" indent="0" marL="0">
+              <a:buNone/>
+            </a:pPr>
+            <a:r>
+              <a:rPr lang="en-US" sz="750" dirty="0">
+                <a:solidFill>
+                  <a:srgbClr val="507060"/>
+                </a:solidFill>
+              </a:rPr>
+              <a:t>Reino Unido</a:t>
+            </a:r>
+            <a:endParaRPr lang="en-US" sz="750" dirty="0"/>
+          </a:p>
+        </p:txBody>
+      </p:sp>
+      <p:sp>
+        <p:nvSpPr>
+          <p:cNvPr id="46" name="Text 44"/>
+          <p:cNvSpPr/>
+          <p:nvPr/>
+        </p:nvSpPr>
+        <p:spPr>
+          <a:xfrm>
+            <a:off x="4334256" y="4224528"/>
+            <a:ext cx="3529584" cy="420624"/>
+          </a:xfrm>
+          <a:prstGeom prst="rect">
+            <a:avLst/>
+          </a:prstGeom>
+          <a:noFill/>
+          <a:ln/>
+        </p:spPr>
+        <p:txBody>
+          <a:bodyPr wrap="square" rtlCol="0" anchor="ctr"/>
+          <a:lstStyle/>
+          <a:p>
+            <a:pPr algn="ctr" indent="0" marL="0">
+              <a:buNone/>
+            </a:pPr>
+            <a:r>
+              <a:rPr lang="en-US" sz="2000" b="1" dirty="0">
                 <a:solidFill>
                   <a:srgbClr val="0D1A12"/>
                 </a:solidFill>
               </a:rPr>
               <a:t>10,886</a:t>
             </a:r>
-            <a:endParaRPr lang="en-US" sz="1300" dirty="0"/>
-          </a:p>
-        </p:txBody>
-      </p:sp>
-      <p:sp>
-        <p:nvSpPr>
-          <p:cNvPr id="46" name="Shape 44"/>
-          <p:cNvSpPr/>
-          <p:nvPr/>
-        </p:nvSpPr>
-        <p:spPr>
-          <a:xfrm>
-            <a:off x="3840480" y="4608576"/>
+            <a:endParaRPr lang="en-US" sz="2000" dirty="0"/>
+          </a:p>
+        </p:txBody>
+      </p:sp>
+      <p:sp>
+        <p:nvSpPr>
+          <p:cNvPr id="47" name="Shape 45"/>
+          <p:cNvSpPr/>
+          <p:nvPr/>
+        </p:nvSpPr>
+        <p:spPr>
+          <a:xfrm>
+            <a:off x="5458968" y="4681728"/>
             <a:ext cx="1280160" cy="237744"/>
           </a:xfrm>
           <a:prstGeom prst="roundRect">
@@ -3361,13 +3397,13 @@
       </p:sp>
       <p:sp>
         <p:nvSpPr>
-          <p:cNvPr id="47" name="Text 45"/>
-          <p:cNvSpPr/>
-          <p:nvPr/>
-        </p:nvSpPr>
-        <p:spPr>
-          <a:xfrm>
-            <a:off x="3840480" y="4608576"/>
+          <p:cNvPr id="48" name="Text 46"/>
+          <p:cNvSpPr/>
+          <p:nvPr/>
+        </p:nvSpPr>
+        <p:spPr>
+          <a:xfrm>
+            <a:off x="5458968" y="4681728"/>
             <a:ext cx="1280160" cy="237744"/>
           </a:xfrm>
           <a:prstGeom prst="rect">
@@ -3397,18 +3433,18 @@
       </p:sp>
       <p:sp>
         <p:nvSpPr>
-          <p:cNvPr id="48" name="Shape 46"/>
-          <p:cNvSpPr/>
-          <p:nvPr/>
-        </p:nvSpPr>
-        <p:spPr>
-          <a:xfrm>
-            <a:off x="6309360" y="3621024"/>
-            <a:ext cx="5577840" cy="713232"/>
+          <p:cNvPr id="49" name="Shape 47"/>
+          <p:cNvSpPr/>
+          <p:nvPr/>
+        </p:nvSpPr>
+        <p:spPr>
+          <a:xfrm>
+            <a:off x="8138160" y="3621024"/>
+            <a:ext cx="3785616" cy="1463040"/>
           </a:xfrm>
           <a:prstGeom prst="roundRect">
             <a:avLst>
-              <a:gd name="adj" fmla="val 12821"/>
+              <a:gd name="adj" fmla="val 6250"/>
             </a:avLst>
           </a:prstGeom>
           <a:solidFill>
@@ -3424,85 +3460,121 @@
       </p:sp>
       <p:sp>
         <p:nvSpPr>
-          <p:cNvPr id="49" name="Text 47"/>
-          <p:cNvSpPr/>
-          <p:nvPr/>
-        </p:nvSpPr>
-        <p:spPr>
-          <a:xfrm>
-            <a:off x="6455664" y="3712464"/>
-            <a:ext cx="3200400" cy="237744"/>
-          </a:xfrm>
-          <a:prstGeom prst="rect">
-            <a:avLst/>
-          </a:prstGeom>
-          <a:noFill/>
-          <a:ln/>
-        </p:spPr>
-        <p:txBody>
-          <a:bodyPr wrap="square" rtlCol="0" anchor="ctr"/>
-          <a:lstStyle/>
-          <a:p>
-            <a:pPr indent="0" marL="0">
-              <a:buNone/>
-            </a:pPr>
-            <a:r>
-              <a:rPr lang="en-US" sz="850" b="1" dirty="0">
+          <p:cNvPr id="50" name="Text 48"/>
+          <p:cNvSpPr/>
+          <p:nvPr/>
+        </p:nvSpPr>
+        <p:spPr>
+          <a:xfrm>
+            <a:off x="8266176" y="3730752"/>
+            <a:ext cx="3529584" cy="274320"/>
+          </a:xfrm>
+          <a:prstGeom prst="rect">
+            <a:avLst/>
+          </a:prstGeom>
+          <a:noFill/>
+          <a:ln/>
+        </p:spPr>
+        <p:txBody>
+          <a:bodyPr wrap="square" rtlCol="0" anchor="ctr"/>
+          <a:lstStyle/>
+          <a:p>
+            <a:pPr algn="ctr" indent="0" marL="0">
+              <a:buNone/>
+            </a:pPr>
+            <a:r>
+              <a:rPr lang="en-US" sz="1000" b="1" dirty="0">
                 <a:solidFill>
                   <a:srgbClr val="2A4830"/>
                 </a:solidFill>
               </a:rPr>
-              <a:t>Nikkei 225 (Japón)</a:t>
-            </a:r>
-            <a:endParaRPr lang="en-US" sz="850" dirty="0"/>
-          </a:p>
-        </p:txBody>
-      </p:sp>
-      <p:sp>
-        <p:nvSpPr>
-          <p:cNvPr id="50" name="Text 48"/>
-          <p:cNvSpPr/>
-          <p:nvPr/>
-        </p:nvSpPr>
-        <p:spPr>
-          <a:xfrm>
-            <a:off x="6455664" y="3968496"/>
-            <a:ext cx="2286000" cy="274320"/>
-          </a:xfrm>
-          <a:prstGeom prst="rect">
-            <a:avLst/>
-          </a:prstGeom>
-          <a:noFill/>
-          <a:ln/>
-        </p:spPr>
-        <p:txBody>
-          <a:bodyPr wrap="square" rtlCol="0" anchor="ctr"/>
-          <a:lstStyle/>
-          <a:p>
-            <a:pPr indent="0" marL="0">
-              <a:buNone/>
-            </a:pPr>
-            <a:r>
-              <a:rPr lang="en-US" sz="1300" b="1" dirty="0">
+              <a:t>🇯🇵  Nikkei 225</a:t>
+            </a:r>
+            <a:endParaRPr lang="en-US" sz="1000" dirty="0"/>
+          </a:p>
+        </p:txBody>
+      </p:sp>
+      <p:sp>
+        <p:nvSpPr>
+          <p:cNvPr id="51" name="Text 49"/>
+          <p:cNvSpPr/>
+          <p:nvPr/>
+        </p:nvSpPr>
+        <p:spPr>
+          <a:xfrm>
+            <a:off x="8266176" y="4005072"/>
+            <a:ext cx="3529584" cy="201168"/>
+          </a:xfrm>
+          <a:prstGeom prst="rect">
+            <a:avLst/>
+          </a:prstGeom>
+          <a:noFill/>
+          <a:ln/>
+        </p:spPr>
+        <p:txBody>
+          <a:bodyPr wrap="square" rtlCol="0" anchor="ctr"/>
+          <a:lstStyle/>
+          <a:p>
+            <a:pPr algn="ctr" indent="0" marL="0">
+              <a:buNone/>
+            </a:pPr>
+            <a:r>
+              <a:rPr lang="en-US" sz="750" dirty="0">
+                <a:solidFill>
+                  <a:srgbClr val="507060"/>
+                </a:solidFill>
+              </a:rPr>
+              <a:t>Japón</a:t>
+            </a:r>
+            <a:endParaRPr lang="en-US" sz="750" dirty="0"/>
+          </a:p>
+        </p:txBody>
+      </p:sp>
+      <p:sp>
+        <p:nvSpPr>
+          <p:cNvPr id="52" name="Text 50"/>
+          <p:cNvSpPr/>
+          <p:nvPr/>
+        </p:nvSpPr>
+        <p:spPr>
+          <a:xfrm>
+            <a:off x="8266176" y="4224528"/>
+            <a:ext cx="3529584" cy="420624"/>
+          </a:xfrm>
+          <a:prstGeom prst="rect">
+            <a:avLst/>
+          </a:prstGeom>
+          <a:noFill/>
+          <a:ln/>
+        </p:spPr>
+        <p:txBody>
+          <a:bodyPr wrap="square" rtlCol="0" anchor="ctr"/>
+          <a:lstStyle/>
+          <a:p>
+            <a:pPr algn="ctr" indent="0" marL="0">
+              <a:buNone/>
+            </a:pPr>
+            <a:r>
+              <a:rPr lang="en-US" sz="2000" b="1" dirty="0">
                 <a:solidFill>
                   <a:srgbClr val="0D1A12"/>
                 </a:solidFill>
               </a:rPr>
               <a:t>66,228</a:t>
             </a:r>
-            <a:endParaRPr lang="en-US" sz="1300" dirty="0"/>
-          </a:p>
-        </p:txBody>
-      </p:sp>
-      <p:sp>
-        <p:nvSpPr>
-          <p:cNvPr id="51" name="Shape 49"/>
-          <p:cNvSpPr/>
-          <p:nvPr/>
-        </p:nvSpPr>
-        <p:spPr>
-          <a:xfrm>
-            <a:off x="10058400" y="3785616"/>
+            <a:endParaRPr lang="en-US" sz="2000" dirty="0"/>
+          </a:p>
+        </p:txBody>
+      </p:sp>
+      <p:sp>
+        <p:nvSpPr>
+          <p:cNvPr id="53" name="Shape 51"/>
+          <p:cNvSpPr/>
+          <p:nvPr/>
+        </p:nvSpPr>
+        <p:spPr>
+          <a:xfrm>
+            <a:off x="9390888" y="4681728"/>
             <a:ext cx="1280160" cy="237744"/>
           </a:xfrm>
           <a:prstGeom prst="roundRect">
@@ -3518,13 +3590,13 @@
       </p:sp>
       <p:sp>
         <p:nvSpPr>
-          <p:cNvPr id="52" name="Text 50"/>
-          <p:cNvSpPr/>
-          <p:nvPr/>
-        </p:nvSpPr>
-        <p:spPr>
-          <a:xfrm>
-            <a:off x="10058400" y="3785616"/>
+          <p:cNvPr id="54" name="Text 52"/>
+          <p:cNvSpPr/>
+          <p:nvPr/>
+        </p:nvSpPr>
+        <p:spPr>
+          <a:xfrm>
+            <a:off x="9390888" y="4681728"/>
             <a:ext cx="1280160" cy="237744"/>
           </a:xfrm>
           <a:prstGeom prst="rect">
@@ -3554,18 +3626,18 @@
       </p:sp>
       <p:sp>
         <p:nvSpPr>
-          <p:cNvPr id="53" name="Shape 51"/>
-          <p:cNvSpPr/>
-          <p:nvPr/>
-        </p:nvSpPr>
-        <p:spPr>
-          <a:xfrm>
-            <a:off x="274320" y="5321808"/>
-            <a:ext cx="11594592" cy="1005840"/>
+          <p:cNvPr id="55" name="Shape 53"/>
+          <p:cNvSpPr/>
+          <p:nvPr/>
+        </p:nvSpPr>
+        <p:spPr>
+          <a:xfrm>
+            <a:off x="274320" y="5266944"/>
+            <a:ext cx="11594592" cy="1060704"/>
           </a:xfrm>
           <a:prstGeom prst="roundRect">
             <a:avLst>
-              <a:gd name="adj" fmla="val 9091"/>
+              <a:gd name="adj" fmla="val 8621"/>
             </a:avLst>
           </a:prstGeom>
           <a:solidFill>
@@ -3581,7 +3653,7 @@
       </p:sp>
       <p:sp>
         <p:nvSpPr>
-          <p:cNvPr id="54" name="Text 52"/>
+          <p:cNvPr id="56" name="Text 54"/>
           <p:cNvSpPr/>
           <p:nvPr/>
         </p:nvSpPr>
@@ -3617,7 +3689,7 @@
       </p:sp>
       <p:sp>
         <p:nvSpPr>
-          <p:cNvPr id="55" name="Text 53"/>
+          <p:cNvPr id="57" name="Text 55"/>
           <p:cNvSpPr/>
           <p:nvPr/>
         </p:nvSpPr>
@@ -3653,7 +3725,7 @@
       </p:sp>
       <p:sp>
         <p:nvSpPr>
-          <p:cNvPr id="56" name="Shape 54"/>
+          <p:cNvPr id="58" name="Shape 56"/>
           <p:cNvSpPr/>
           <p:nvPr/>
         </p:nvSpPr>
@@ -3673,7 +3745,7 @@
       </p:sp>
       <p:sp>
         <p:nvSpPr>
-          <p:cNvPr id="57" name="Text 55"/>
+          <p:cNvPr id="59" name="Text 57"/>
           <p:cNvSpPr/>
           <p:nvPr/>
         </p:nvSpPr>

</xml_diff>